<commit_message>
Build the Group_1 submission folder from run 20261029T073854762519Z
</commit_message>
<xml_diff>
--- a/Group_1/02_Presentation/Presentation.pptx
+++ b/Group_1/02_Presentation/Presentation.pptx
@@ -1147,12 +1147,12 @@
           <a:lstStyle/>
           <a:p>
             <a:r>
-              <a:t>[Kiet | 0:00-0:15 | 15 s]</a:t>
+              <a:t>[Phong | 0:00-0:15 | 15 s]</a:t>
             </a:r>
           </a:p>
           <a:p>
             <a:r>
-              <a:t>Good morning, Professor, and everyone. We are Group 1, presenting Topic 7: profit-aware telecom churn and retention targeting. Hieu, Dung and I will present, and Phong will demo our dashboard at the end.</a:t>
+              <a:t>Good morning, Professor, and everyone. We are Group 1, presenting Topic 7: profit-aware telecom churn and retention targeting. Hieu, Dung and I will present, and Kiet will demo our dashboard at the end.</a:t>
             </a:r>
           </a:p>
         </p:txBody>
@@ -1404,7 +1404,7 @@
           </a:p>
           <a:p>
             <a:r>
-              <a:t>So our recommendation to the Head of Retention is to adopt expected-value targeting with segment offers, but to launch it as a randomised pilot. One wave of 1,620 customers from the recommended list is split at random: half receive the offer, half are held out. After 90 days we measure the real save rate of this offer mix, which we assume to be 22.6%. The decision rule is agreed now: go if the effect is significant and at least the break-even of 15.6%; stop if it is clearly below. The offered half costs about $22,875, and if our assumption holds, the rule says go 97% of the time. A decision is ready about 19 weeks after approval. Phong will now show our dashboard.</a:t>
+              <a:t>So our recommendation to the Head of Retention is to adopt expected-value targeting with segment offers, but to launch it as a randomised pilot. One wave of 1,620 customers from the recommended list is split at random: half receive the offer, half are held out. After 90 days we measure the real save rate of this offer mix, which we assume to be 22.6%. The decision rule is agreed now: go if the effect is significant and at least the break-even of 15.6%; stop if it is clearly below. The offered half costs about $22,875, and if our assumption holds, the rule says go 97% of the time. A decision is ready about 19 weeks after approval. Kiet will now show our dashboard.</a:t>
             </a:r>
           </a:p>
         </p:txBody>
@@ -1462,7 +1462,7 @@
           <a:lstStyle/>
           <a:p>
             <a:r>
-              <a:t>[Phong | live demo before the closing words, not part of the 8-minute talk | full timed steps in demo-script.md]</a:t>
+              <a:t>[Kiet | live demo before the closing words, not part of the 8-minute talk | full timed steps in demo-script.md]</a:t>
             </a:r>
           </a:p>
           <a:p>
@@ -1749,7 +1749,7 @@
           <a:lstStyle/>
           <a:p>
             <a:r>
-              <a:t>[Kiet | 0:15-0:25 | 10 s]</a:t>
+              <a:t>[Phong | 0:15-0:25 | 10 s]</a:t>
             </a:r>
           </a:p>
           <a:p>
@@ -1812,7 +1812,7 @@
           <a:lstStyle/>
           <a:p>
             <a:r>
-              <a:t>[Kiet | 0:25-1:15 | 50 s]</a:t>
+              <a:t>[Phong | 0:25-1:15 | 50 s]</a:t>
             </a:r>
           </a:p>
           <a:p>
@@ -1875,7 +1875,7 @@
           <a:lstStyle/>
           <a:p>
             <a:r>
-              <a:t>[Kiet | 1:15-2:00 | 45 s]</a:t>
+              <a:t>[Phong | 1:15-2:00 | 45 s]</a:t>
             </a:r>
           </a:p>
           <a:p>
@@ -1938,7 +1938,7 @@
           <a:lstStyle/>
           <a:p>
             <a:r>
-              <a:t>[Kiet | 2:00-2:40 | 40 s]</a:t>
+              <a:t>[Phong | 2:00-2:40 | 40 s]</a:t>
             </a:r>
           </a:p>
           <a:p>
@@ -2006,7 +2006,7 @@
           </a:p>
           <a:p>
             <a:r>
-              <a:t>Thank you, Kiet. I will start with the churn model.</a:t>
+              <a:t>Thank you, Phong. I will start with the churn model.</a:t>
             </a:r>
           </a:p>
         </p:txBody>
@@ -42062,7 +42062,7 @@
                           </a:solidFill>
                           <a:latin typeface="Calibri"/>
                         </a:rPr>
-                        <a:t>Presentation slides and speaker script; review and quality assurance of code and report</a:t>
+                        <a:t>Presentation slides and executive brief; review and quality assurance of code and report</a:t>
                       </a:r>
                     </a:p>
                   </a:txBody>
@@ -42182,7 +42182,7 @@
                 </a:solidFill>
                 <a:latin typeface="Calibri"/>
               </a:rPr>
-              <a:t>Phong runs the live demo; Kiet, Hieu and Dung give the talk. The same table is in the final report.</a:t>
+              <a:t>Kiet runs the live demo; Phong, Hieu and Dung give the talk. The same table is in the final report.</a:t>
             </a:r>
           </a:p>
         </p:txBody>

</xml_diff>